<commit_message>
Deploying to gh-pages from @ ShiResearchGroup/shiresearchgroup.github.io@a7848f5a45b0a29256e27afb90ae79dc93b7d9dd 🚀
</commit_message>
<xml_diff>
--- a/assets/img/image_slider/images.pptx
+++ b/assets/img/image_slider/images.pptx
@@ -9,7 +9,8 @@
     <p:sldId id="260" r:id="rId3"/>
     <p:sldId id="258" r:id="rId4"/>
     <p:sldId id="259" r:id="rId5"/>
-    <p:sldId id="257" r:id="rId6"/>
+    <p:sldId id="261" r:id="rId6"/>
+    <p:sldId id="257" r:id="rId7"/>
   </p:sldIdLst>
   <p:sldSz cx="12192000" cy="6858000"/>
   <p:notesSz cx="6858000" cy="9144000"/>
@@ -263,7 +264,7 @@
           <a:p>
             <a:fld id="{4A16C27B-D470-42F2-92F9-5356A7F22CB8}" type="datetimeFigureOut">
               <a:rPr lang="en-US" smtClean="0"/>
-              <a:t>4/11/2026</a:t>
+              <a:t>5/29/2026</a:t>
             </a:fld>
             <a:endParaRPr lang="en-US"/>
           </a:p>
@@ -461,7 +462,7 @@
           <a:p>
             <a:fld id="{4A16C27B-D470-42F2-92F9-5356A7F22CB8}" type="datetimeFigureOut">
               <a:rPr lang="en-US" smtClean="0"/>
-              <a:t>4/11/2026</a:t>
+              <a:t>5/29/2026</a:t>
             </a:fld>
             <a:endParaRPr lang="en-US"/>
           </a:p>
@@ -669,7 +670,7 @@
           <a:p>
             <a:fld id="{4A16C27B-D470-42F2-92F9-5356A7F22CB8}" type="datetimeFigureOut">
               <a:rPr lang="en-US" smtClean="0"/>
-              <a:t>4/11/2026</a:t>
+              <a:t>5/29/2026</a:t>
             </a:fld>
             <a:endParaRPr lang="en-US"/>
           </a:p>
@@ -867,7 +868,7 @@
           <a:p>
             <a:fld id="{4A16C27B-D470-42F2-92F9-5356A7F22CB8}" type="datetimeFigureOut">
               <a:rPr lang="en-US" smtClean="0"/>
-              <a:t>4/11/2026</a:t>
+              <a:t>5/29/2026</a:t>
             </a:fld>
             <a:endParaRPr lang="en-US"/>
           </a:p>
@@ -1142,7 +1143,7 @@
           <a:p>
             <a:fld id="{4A16C27B-D470-42F2-92F9-5356A7F22CB8}" type="datetimeFigureOut">
               <a:rPr lang="en-US" smtClean="0"/>
-              <a:t>4/11/2026</a:t>
+              <a:t>5/29/2026</a:t>
             </a:fld>
             <a:endParaRPr lang="en-US"/>
           </a:p>
@@ -1407,7 +1408,7 @@
           <a:p>
             <a:fld id="{4A16C27B-D470-42F2-92F9-5356A7F22CB8}" type="datetimeFigureOut">
               <a:rPr lang="en-US" smtClean="0"/>
-              <a:t>4/11/2026</a:t>
+              <a:t>5/29/2026</a:t>
             </a:fld>
             <a:endParaRPr lang="en-US"/>
           </a:p>
@@ -1819,7 +1820,7 @@
           <a:p>
             <a:fld id="{4A16C27B-D470-42F2-92F9-5356A7F22CB8}" type="datetimeFigureOut">
               <a:rPr lang="en-US" smtClean="0"/>
-              <a:t>4/11/2026</a:t>
+              <a:t>5/29/2026</a:t>
             </a:fld>
             <a:endParaRPr lang="en-US"/>
           </a:p>
@@ -1960,7 +1961,7 @@
           <a:p>
             <a:fld id="{4A16C27B-D470-42F2-92F9-5356A7F22CB8}" type="datetimeFigureOut">
               <a:rPr lang="en-US" smtClean="0"/>
-              <a:t>4/11/2026</a:t>
+              <a:t>5/29/2026</a:t>
             </a:fld>
             <a:endParaRPr lang="en-US"/>
           </a:p>
@@ -2073,7 +2074,7 @@
           <a:p>
             <a:fld id="{4A16C27B-D470-42F2-92F9-5356A7F22CB8}" type="datetimeFigureOut">
               <a:rPr lang="en-US" smtClean="0"/>
-              <a:t>4/11/2026</a:t>
+              <a:t>5/29/2026</a:t>
             </a:fld>
             <a:endParaRPr lang="en-US"/>
           </a:p>
@@ -2384,7 +2385,7 @@
           <a:p>
             <a:fld id="{4A16C27B-D470-42F2-92F9-5356A7F22CB8}" type="datetimeFigureOut">
               <a:rPr lang="en-US" smtClean="0"/>
-              <a:t>4/11/2026</a:t>
+              <a:t>5/29/2026</a:t>
             </a:fld>
             <a:endParaRPr lang="en-US"/>
           </a:p>
@@ -2672,7 +2673,7 @@
           <a:p>
             <a:fld id="{4A16C27B-D470-42F2-92F9-5356A7F22CB8}" type="datetimeFigureOut">
               <a:rPr lang="en-US" smtClean="0"/>
-              <a:t>4/11/2026</a:t>
+              <a:t>5/29/2026</a:t>
             </a:fld>
             <a:endParaRPr lang="en-US"/>
           </a:p>
@@ -2913,7 +2914,7 @@
           <a:p>
             <a:fld id="{4A16C27B-D470-42F2-92F9-5356A7F22CB8}" type="datetimeFigureOut">
               <a:rPr lang="en-US" smtClean="0"/>
-              <a:t>4/11/2026</a:t>
+              <a:t>5/29/2026</a:t>
             </a:fld>
             <a:endParaRPr lang="en-US"/>
           </a:p>
@@ -4041,6 +4042,217 @@
 </file>
 
 <file path=ppt/slides/slide5.xml><?xml version="1.0" encoding="utf-8"?>
+<p:sld xmlns:a="http://schemas.openxmlformats.org/drawingml/2006/main" xmlns:r="http://schemas.openxmlformats.org/officeDocument/2006/relationships" xmlns:p="http://schemas.openxmlformats.org/presentationml/2006/main">
+  <p:cSld>
+    <p:spTree>
+      <p:nvGrpSpPr>
+        <p:cNvPr id="1" name="">
+          <a:extLst>
+            <a:ext uri="{FF2B5EF4-FFF2-40B4-BE49-F238E27FC236}">
+              <a16:creationId xmlns:a16="http://schemas.microsoft.com/office/drawing/2014/main" id="{2D17F470-E331-3ACC-7DCB-B6C90C1D2379}"/>
+            </a:ext>
+          </a:extLst>
+        </p:cNvPr>
+        <p:cNvGrpSpPr/>
+        <p:nvPr/>
+      </p:nvGrpSpPr>
+      <p:grpSpPr>
+        <a:xfrm>
+          <a:off x="0" y="0"/>
+          <a:ext cx="0" cy="0"/>
+          <a:chOff x="0" y="0"/>
+          <a:chExt cx="0" cy="0"/>
+        </a:xfrm>
+      </p:grpSpPr>
+      <p:sp>
+        <p:nvSpPr>
+          <p:cNvPr id="6" name="Rectangle 5">
+            <a:extLst>
+              <a:ext uri="{FF2B5EF4-FFF2-40B4-BE49-F238E27FC236}">
+                <a16:creationId xmlns:a16="http://schemas.microsoft.com/office/drawing/2014/main" id="{EE331378-5A7F-8AEF-C66F-D4CCAE575397}"/>
+              </a:ext>
+            </a:extLst>
+          </p:cNvPr>
+          <p:cNvSpPr/>
+          <p:nvPr/>
+        </p:nvSpPr>
+        <p:spPr>
+          <a:xfrm>
+            <a:off x="0" y="4632960"/>
+            <a:ext cx="12191999" cy="1465312"/>
+          </a:xfrm>
+          <a:prstGeom prst="rect">
+            <a:avLst/>
+          </a:prstGeom>
+          <a:solidFill>
+            <a:srgbClr val="000000">
+              <a:alpha val="60000"/>
+            </a:srgbClr>
+          </a:solidFill>
+          <a:ln>
+            <a:noFill/>
+          </a:ln>
+        </p:spPr>
+        <p:style>
+          <a:lnRef idx="2">
+            <a:schemeClr val="accent1">
+              <a:shade val="15000"/>
+            </a:schemeClr>
+          </a:lnRef>
+          <a:fillRef idx="1">
+            <a:schemeClr val="accent1"/>
+          </a:fillRef>
+          <a:effectRef idx="0">
+            <a:schemeClr val="accent1"/>
+          </a:effectRef>
+          <a:fontRef idx="minor">
+            <a:schemeClr val="lt1"/>
+          </a:fontRef>
+        </p:style>
+        <p:txBody>
+          <a:bodyPr rtlCol="0" anchor="ctr"/>
+          <a:lstStyle/>
+          <a:p>
+            <a:pPr marL="457200"/>
+            <a:endParaRPr lang="en-US" sz="2400" dirty="0"/>
+          </a:p>
+        </p:txBody>
+      </p:sp>
+      <p:sp>
+        <p:nvSpPr>
+          <p:cNvPr id="7" name="TextBox 6">
+            <a:extLst>
+              <a:ext uri="{FF2B5EF4-FFF2-40B4-BE49-F238E27FC236}">
+                <a16:creationId xmlns:a16="http://schemas.microsoft.com/office/drawing/2014/main" id="{882A3AC1-1105-6FD3-3ECC-C725C5765A4C}"/>
+              </a:ext>
+            </a:extLst>
+          </p:cNvPr>
+          <p:cNvSpPr txBox="1"/>
+          <p:nvPr/>
+        </p:nvSpPr>
+        <p:spPr>
+          <a:xfrm>
+            <a:off x="540065" y="5134783"/>
+            <a:ext cx="11019099" cy="461665"/>
+          </a:xfrm>
+          <a:prstGeom prst="rect">
+            <a:avLst/>
+          </a:prstGeom>
+          <a:noFill/>
+        </p:spPr>
+        <p:txBody>
+          <a:bodyPr wrap="square" rtlCol="0">
+            <a:spAutoFit/>
+          </a:bodyPr>
+          <a:lstStyle/>
+          <a:p>
+            <a:r>
+              <a:rPr lang="en-US" sz="2400" dirty="0">
+                <a:solidFill>
+                  <a:schemeClr val="bg1"/>
+                </a:solidFill>
+              </a:rPr>
+              <a:t>PoroNet is out in the </a:t>
+            </a:r>
+            <a:r>
+              <a:rPr lang="en-US" sz="2400" i="1" dirty="0">
+                <a:solidFill>
+                  <a:schemeClr val="bg1"/>
+                </a:solidFill>
+              </a:rPr>
+              <a:t>Journal of Chemical Theory and Computation</a:t>
+            </a:r>
+            <a:r>
+              <a:rPr lang="en-US" sz="2400" dirty="0">
+                <a:solidFill>
+                  <a:schemeClr val="bg1"/>
+                </a:solidFill>
+              </a:rPr>
+              <a:t>. Check it out! </a:t>
+            </a:r>
+          </a:p>
+        </p:txBody>
+      </p:sp>
+      <p:pic>
+        <p:nvPicPr>
+          <p:cNvPr id="4" name="Picture 3">
+            <a:extLst>
+              <a:ext uri="{FF2B5EF4-FFF2-40B4-BE49-F238E27FC236}">
+                <a16:creationId xmlns:a16="http://schemas.microsoft.com/office/drawing/2014/main" id="{75C9832C-3707-7D78-DE09-18D8659C6169}"/>
+              </a:ext>
+            </a:extLst>
+          </p:cNvPr>
+          <p:cNvPicPr>
+            <a:picLocks noChangeAspect="1"/>
+          </p:cNvPicPr>
+          <p:nvPr/>
+        </p:nvPicPr>
+        <p:blipFill>
+          <a:blip r:embed="rId2"/>
+          <a:stretch>
+            <a:fillRect/>
+          </a:stretch>
+        </p:blipFill>
+        <p:spPr>
+          <a:xfrm>
+            <a:off x="331305" y="1044160"/>
+            <a:ext cx="6983895" cy="2347204"/>
+          </a:xfrm>
+          <a:prstGeom prst="rect">
+            <a:avLst/>
+          </a:prstGeom>
+        </p:spPr>
+      </p:pic>
+      <p:pic>
+        <p:nvPicPr>
+          <p:cNvPr id="8" name="Picture 7">
+            <a:extLst>
+              <a:ext uri="{FF2B5EF4-FFF2-40B4-BE49-F238E27FC236}">
+                <a16:creationId xmlns:a16="http://schemas.microsoft.com/office/drawing/2014/main" id="{DDB361A9-040A-6001-5D26-7147C9601C54}"/>
+              </a:ext>
+            </a:extLst>
+          </p:cNvPr>
+          <p:cNvPicPr>
+            <a:picLocks noChangeAspect="1"/>
+          </p:cNvPicPr>
+          <p:nvPr/>
+        </p:nvPicPr>
+        <p:blipFill>
+          <a:blip r:embed="rId3">
+            <a:extLst>
+              <a:ext uri="{28A0092B-C50C-407E-A947-70E740481C1C}">
+                <a14:useLocalDpi xmlns:a14="http://schemas.microsoft.com/office/drawing/2010/main" val="0"/>
+              </a:ext>
+            </a:extLst>
+          </a:blip>
+          <a:stretch>
+            <a:fillRect/>
+          </a:stretch>
+        </p:blipFill>
+        <p:spPr>
+          <a:xfrm>
+            <a:off x="7426250" y="1044160"/>
+            <a:ext cx="4655543" cy="2586936"/>
+          </a:xfrm>
+          <a:prstGeom prst="rect">
+            <a:avLst/>
+          </a:prstGeom>
+        </p:spPr>
+      </p:pic>
+    </p:spTree>
+    <p:extLst>
+      <p:ext uri="{BB962C8B-B14F-4D97-AF65-F5344CB8AC3E}">
+        <p14:creationId xmlns:p14="http://schemas.microsoft.com/office/powerpoint/2010/main" val="2363919763"/>
+      </p:ext>
+    </p:extLst>
+  </p:cSld>
+  <p:clrMapOvr>
+    <a:masterClrMapping/>
+  </p:clrMapOvr>
+</p:sld>
+</file>
+
+<file path=ppt/slides/slide6.xml><?xml version="1.0" encoding="utf-8"?>
 <p:sld xmlns:a="http://schemas.openxmlformats.org/drawingml/2006/main" xmlns:r="http://schemas.openxmlformats.org/officeDocument/2006/relationships" xmlns:p="http://schemas.openxmlformats.org/presentationml/2006/main">
   <p:cSld>
     <p:spTree>

</xml_diff>

<commit_message>
Deploying to gh-pages from @ ShiResearchGroup/shiresearchgroup.github.io@8c88881af7c2ef5fcd8f3f19c2ab95f1a24bf3e1 🚀
</commit_message>
<xml_diff>
--- a/assets/img/image_slider/images.pptx
+++ b/assets/img/image_slider/images.pptx
@@ -3381,8 +3381,8 @@
         </p:nvSpPr>
         <p:spPr>
           <a:xfrm>
-            <a:off x="0" y="4632960"/>
-            <a:ext cx="12191999" cy="1465312"/>
+            <a:off x="1" y="4946128"/>
+            <a:ext cx="12191999" cy="1152144"/>
           </a:xfrm>
           <a:prstGeom prst="rect">
             <a:avLst/>
@@ -3435,7 +3435,7 @@
         </p:nvSpPr>
         <p:spPr>
           <a:xfrm>
-            <a:off x="586449" y="5134783"/>
+            <a:off x="586450" y="5291367"/>
             <a:ext cx="11019099" cy="461665"/>
           </a:xfrm>
           <a:prstGeom prst="rect">
@@ -3547,8 +3547,8 @@
         </p:nvSpPr>
         <p:spPr>
           <a:xfrm>
-            <a:off x="0" y="4632960"/>
-            <a:ext cx="12191999" cy="1465312"/>
+            <a:off x="-2" y="4946128"/>
+            <a:ext cx="12191999" cy="1152144"/>
           </a:xfrm>
           <a:prstGeom prst="rect">
             <a:avLst/>
@@ -3601,7 +3601,7 @@
         </p:nvSpPr>
         <p:spPr>
           <a:xfrm>
-            <a:off x="586449" y="5134783"/>
+            <a:off x="586447" y="5291367"/>
             <a:ext cx="11019099" cy="461665"/>
           </a:xfrm>
           <a:prstGeom prst="rect">
@@ -3861,7 +3861,7 @@
         </p:blipFill>
         <p:spPr bwMode="auto">
           <a:xfrm>
-            <a:off x="8822394" y="946102"/>
+            <a:off x="404191" y="1733829"/>
             <a:ext cx="2931671" cy="3057707"/>
           </a:xfrm>
           <a:prstGeom prst="rect">
@@ -3906,13 +3906,15 @@
               </a:clrTo>
             </a:clrChange>
           </a:blip>
-          <a:srcRect r="974"/>
-          <a:stretch/>
+          <a:srcRect t="44279" r="974" b="19191"/>
+          <a:stretch>
+            <a:fillRect/>
+          </a:stretch>
         </p:blipFill>
         <p:spPr>
           <a:xfrm>
-            <a:off x="286506" y="860803"/>
-            <a:ext cx="8187712" cy="3143006"/>
+            <a:off x="3600097" y="266457"/>
+            <a:ext cx="8187712" cy="1148155"/>
           </a:xfrm>
           <a:prstGeom prst="rect">
             <a:avLst/>
@@ -3933,8 +3935,8 @@
         </p:nvSpPr>
         <p:spPr>
           <a:xfrm>
-            <a:off x="0" y="4632960"/>
-            <a:ext cx="12191999" cy="1465312"/>
+            <a:off x="0" y="4950116"/>
+            <a:ext cx="12191999" cy="1148155"/>
           </a:xfrm>
           <a:prstGeom prst="rect">
             <a:avLst/>
@@ -3987,7 +3989,7 @@
         </p:nvSpPr>
         <p:spPr>
           <a:xfrm>
-            <a:off x="586448" y="4950117"/>
+            <a:off x="586449" y="5108694"/>
             <a:ext cx="11019099" cy="830997"/>
           </a:xfrm>
           <a:prstGeom prst="rect">
@@ -4024,6 +4026,209 @@
                 </a:solidFill>
               </a:rPr>
               <a:t>. Check it out! </a:t>
+            </a:r>
+          </a:p>
+        </p:txBody>
+      </p:sp>
+      <p:pic>
+        <p:nvPicPr>
+          <p:cNvPr id="2" name="Picture 1">
+            <a:extLst>
+              <a:ext uri="{FF2B5EF4-FFF2-40B4-BE49-F238E27FC236}">
+                <a16:creationId xmlns:a16="http://schemas.microsoft.com/office/drawing/2014/main" id="{455372C3-1A1C-2F6C-996D-9168C4483BD8}"/>
+              </a:ext>
+            </a:extLst>
+          </p:cNvPr>
+          <p:cNvPicPr>
+            <a:picLocks noChangeAspect="1"/>
+          </p:cNvPicPr>
+          <p:nvPr/>
+        </p:nvPicPr>
+        <p:blipFill>
+          <a:blip r:embed="rId4"/>
+          <a:srcRect r="66793" b="76734"/>
+          <a:stretch>
+            <a:fillRect/>
+          </a:stretch>
+        </p:blipFill>
+        <p:spPr>
+          <a:xfrm>
+            <a:off x="404191" y="462375"/>
+            <a:ext cx="3009980" cy="708779"/>
+          </a:xfrm>
+          <a:prstGeom prst="rect">
+            <a:avLst/>
+          </a:prstGeom>
+        </p:spPr>
+      </p:pic>
+      <p:pic>
+        <p:nvPicPr>
+          <p:cNvPr id="8" name="Picture 7">
+            <a:extLst>
+              <a:ext uri="{FF2B5EF4-FFF2-40B4-BE49-F238E27FC236}">
+                <a16:creationId xmlns:a16="http://schemas.microsoft.com/office/drawing/2014/main" id="{D9975E58-20A0-477C-E2D3-C04B32454DBA}"/>
+              </a:ext>
+            </a:extLst>
+          </p:cNvPr>
+          <p:cNvPicPr>
+            <a:picLocks noChangeAspect="1"/>
+          </p:cNvPicPr>
+          <p:nvPr/>
+        </p:nvPicPr>
+        <p:blipFill>
+          <a:blip r:embed="rId3">
+            <a:clrChange>
+              <a:clrFrom>
+                <a:srgbClr val="FFFFFF"/>
+              </a:clrFrom>
+              <a:clrTo>
+                <a:srgbClr val="FFFFFF">
+                  <a:alpha val="0"/>
+                </a:srgbClr>
+              </a:clrTo>
+            </a:clrChange>
+          </a:blip>
+          <a:srcRect t="82593" r="60505"/>
+          <a:stretch>
+            <a:fillRect/>
+          </a:stretch>
+        </p:blipFill>
+        <p:spPr>
+          <a:xfrm>
+            <a:off x="8188024" y="1217736"/>
+            <a:ext cx="3265597" cy="547099"/>
+          </a:xfrm>
+          <a:prstGeom prst="rect">
+            <a:avLst/>
+          </a:prstGeom>
+        </p:spPr>
+      </p:pic>
+      <p:pic>
+        <p:nvPicPr>
+          <p:cNvPr id="10" name="Picture 9">
+            <a:extLst>
+              <a:ext uri="{FF2B5EF4-FFF2-40B4-BE49-F238E27FC236}">
+                <a16:creationId xmlns:a16="http://schemas.microsoft.com/office/drawing/2014/main" id="{E1922376-E743-E490-E6CC-758759DD6B43}"/>
+              </a:ext>
+            </a:extLst>
+          </p:cNvPr>
+          <p:cNvPicPr>
+            <a:picLocks noChangeAspect="1"/>
+          </p:cNvPicPr>
+          <p:nvPr/>
+        </p:nvPicPr>
+        <p:blipFill>
+          <a:blip r:embed="rId5"/>
+          <a:stretch>
+            <a:fillRect/>
+          </a:stretch>
+        </p:blipFill>
+        <p:spPr>
+          <a:xfrm>
+            <a:off x="3600097" y="2223050"/>
+            <a:ext cx="4112668" cy="2591544"/>
+          </a:xfrm>
+          <a:prstGeom prst="rect">
+            <a:avLst/>
+          </a:prstGeom>
+        </p:spPr>
+      </p:pic>
+      <p:sp>
+        <p:nvSpPr>
+          <p:cNvPr id="11" name="TextBox 10">
+            <a:extLst>
+              <a:ext uri="{FF2B5EF4-FFF2-40B4-BE49-F238E27FC236}">
+                <a16:creationId xmlns:a16="http://schemas.microsoft.com/office/drawing/2014/main" id="{21B3CABC-99FC-24AF-FAC8-F8A985FF9619}"/>
+              </a:ext>
+            </a:extLst>
+          </p:cNvPr>
+          <p:cNvSpPr txBox="1"/>
+          <p:nvPr/>
+        </p:nvSpPr>
+        <p:spPr>
+          <a:xfrm>
+            <a:off x="4582471" y="1837672"/>
+            <a:ext cx="2695750" cy="369332"/>
+          </a:xfrm>
+          <a:prstGeom prst="rect">
+            <a:avLst/>
+          </a:prstGeom>
+          <a:noFill/>
+        </p:spPr>
+        <p:txBody>
+          <a:bodyPr wrap="square" rtlCol="0">
+            <a:spAutoFit/>
+          </a:bodyPr>
+          <a:lstStyle/>
+          <a:p>
+            <a:r>
+              <a:rPr lang="en-US" b="1" dirty="0"/>
+              <a:t>GCMC with ML potential</a:t>
+            </a:r>
+          </a:p>
+        </p:txBody>
+      </p:sp>
+      <p:pic>
+        <p:nvPicPr>
+          <p:cNvPr id="13" name="Picture 12">
+            <a:extLst>
+              <a:ext uri="{FF2B5EF4-FFF2-40B4-BE49-F238E27FC236}">
+                <a16:creationId xmlns:a16="http://schemas.microsoft.com/office/drawing/2014/main" id="{ED33C62E-AEDB-61C2-D75E-641784311A89}"/>
+              </a:ext>
+            </a:extLst>
+          </p:cNvPr>
+          <p:cNvPicPr>
+            <a:picLocks noChangeAspect="1"/>
+          </p:cNvPicPr>
+          <p:nvPr/>
+        </p:nvPicPr>
+        <p:blipFill>
+          <a:blip r:embed="rId6"/>
+          <a:stretch>
+            <a:fillRect/>
+          </a:stretch>
+        </p:blipFill>
+        <p:spPr>
+          <a:xfrm>
+            <a:off x="7779027" y="2223050"/>
+            <a:ext cx="4083592" cy="2500159"/>
+          </a:xfrm>
+          <a:prstGeom prst="rect">
+            <a:avLst/>
+          </a:prstGeom>
+        </p:spPr>
+      </p:pic>
+      <p:sp>
+        <p:nvSpPr>
+          <p:cNvPr id="14" name="TextBox 13">
+            <a:extLst>
+              <a:ext uri="{FF2B5EF4-FFF2-40B4-BE49-F238E27FC236}">
+                <a16:creationId xmlns:a16="http://schemas.microsoft.com/office/drawing/2014/main" id="{E3D7E828-63D7-7EBD-0AD7-3304BAE49513}"/>
+              </a:ext>
+            </a:extLst>
+          </p:cNvPr>
+          <p:cNvSpPr txBox="1"/>
+          <p:nvPr/>
+        </p:nvSpPr>
+        <p:spPr>
+          <a:xfrm>
+            <a:off x="8799442" y="1853718"/>
+            <a:ext cx="2285997" cy="369332"/>
+          </a:xfrm>
+          <a:prstGeom prst="rect">
+            <a:avLst/>
+          </a:prstGeom>
+          <a:noFill/>
+        </p:spPr>
+        <p:txBody>
+          <a:bodyPr wrap="square" rtlCol="0">
+            <a:spAutoFit/>
+          </a:bodyPr>
+          <a:lstStyle/>
+          <a:p>
+            <a:r>
+              <a:rPr lang="en-US" b="1" dirty="0"/>
+              <a:t>GPU acceleration</a:t>
             </a:r>
           </a:p>
         </p:txBody>
@@ -4064,12 +4269,42 @@
           <a:chExt cx="0" cy="0"/>
         </a:xfrm>
       </p:grpSpPr>
-      <p:sp>
-        <p:nvSpPr>
-          <p:cNvPr id="6" name="Rectangle 5">
-            <a:extLst>
-              <a:ext uri="{FF2B5EF4-FFF2-40B4-BE49-F238E27FC236}">
-                <a16:creationId xmlns:a16="http://schemas.microsoft.com/office/drawing/2014/main" id="{EE331378-5A7F-8AEF-C66F-D4CCAE575397}"/>
+      <p:pic>
+        <p:nvPicPr>
+          <p:cNvPr id="5" name="Picture 4">
+            <a:extLst>
+              <a:ext uri="{FF2B5EF4-FFF2-40B4-BE49-F238E27FC236}">
+                <a16:creationId xmlns:a16="http://schemas.microsoft.com/office/drawing/2014/main" id="{46FBDBDE-6837-0984-0903-1E13A98BC112}"/>
+              </a:ext>
+            </a:extLst>
+          </p:cNvPr>
+          <p:cNvPicPr>
+            <a:picLocks noChangeAspect="1"/>
+          </p:cNvPicPr>
+          <p:nvPr/>
+        </p:nvPicPr>
+        <p:blipFill>
+          <a:blip r:embed="rId2"/>
+          <a:stretch>
+            <a:fillRect/>
+          </a:stretch>
+        </p:blipFill>
+        <p:spPr>
+          <a:xfrm>
+            <a:off x="485377" y="1375108"/>
+            <a:ext cx="11221239" cy="4127883"/>
+          </a:xfrm>
+          <a:prstGeom prst="rect">
+            <a:avLst/>
+          </a:prstGeom>
+        </p:spPr>
+      </p:pic>
+      <p:sp>
+        <p:nvSpPr>
+          <p:cNvPr id="10" name="Rectangle 9">
+            <a:extLst>
+              <a:ext uri="{FF2B5EF4-FFF2-40B4-BE49-F238E27FC236}">
+                <a16:creationId xmlns:a16="http://schemas.microsoft.com/office/drawing/2014/main" id="{6D1C3029-24DA-F1D1-3C09-D66D0CD5A562}"/>
               </a:ext>
             </a:extLst>
           </p:cNvPr>
@@ -4078,8 +4313,8 @@
         </p:nvSpPr>
         <p:spPr>
           <a:xfrm>
-            <a:off x="0" y="4632960"/>
-            <a:ext cx="12191999" cy="1465312"/>
+            <a:off x="0" y="4950116"/>
+            <a:ext cx="12191999" cy="1148155"/>
           </a:xfrm>
           <a:prstGeom prst="rect">
             <a:avLst/>
@@ -4118,6 +4353,120 @@
           </a:p>
         </p:txBody>
       </p:sp>
+      <p:pic>
+        <p:nvPicPr>
+          <p:cNvPr id="4" name="Picture 3">
+            <a:extLst>
+              <a:ext uri="{FF2B5EF4-FFF2-40B4-BE49-F238E27FC236}">
+                <a16:creationId xmlns:a16="http://schemas.microsoft.com/office/drawing/2014/main" id="{75C9832C-3707-7D78-DE09-18D8659C6169}"/>
+              </a:ext>
+            </a:extLst>
+          </p:cNvPr>
+          <p:cNvPicPr>
+            <a:picLocks noChangeAspect="1"/>
+          </p:cNvPicPr>
+          <p:nvPr/>
+        </p:nvPicPr>
+        <p:blipFill>
+          <a:blip r:embed="rId3"/>
+          <a:srcRect r="66793" b="76734"/>
+          <a:stretch>
+            <a:fillRect/>
+          </a:stretch>
+        </p:blipFill>
+        <p:spPr>
+          <a:xfrm>
+            <a:off x="404191" y="462375"/>
+            <a:ext cx="3009980" cy="708779"/>
+          </a:xfrm>
+          <a:prstGeom prst="rect">
+            <a:avLst/>
+          </a:prstGeom>
+        </p:spPr>
+      </p:pic>
+      <p:pic>
+        <p:nvPicPr>
+          <p:cNvPr id="2" name="Picture 1">
+            <a:extLst>
+              <a:ext uri="{FF2B5EF4-FFF2-40B4-BE49-F238E27FC236}">
+                <a16:creationId xmlns:a16="http://schemas.microsoft.com/office/drawing/2014/main" id="{2ABC468C-971C-4245-3A9E-0B17FB513D64}"/>
+              </a:ext>
+            </a:extLst>
+          </p:cNvPr>
+          <p:cNvPicPr>
+            <a:picLocks noChangeAspect="1"/>
+          </p:cNvPicPr>
+          <p:nvPr/>
+        </p:nvPicPr>
+        <p:blipFill>
+          <a:blip r:embed="rId3"/>
+          <a:srcRect t="47000" b="17849"/>
+          <a:stretch>
+            <a:fillRect/>
+          </a:stretch>
+        </p:blipFill>
+        <p:spPr>
+          <a:xfrm>
+            <a:off x="3561619" y="211719"/>
+            <a:ext cx="8226190" cy="971837"/>
+          </a:xfrm>
+          <a:prstGeom prst="rect">
+            <a:avLst/>
+          </a:prstGeom>
+        </p:spPr>
+      </p:pic>
+      <p:sp>
+        <p:nvSpPr>
+          <p:cNvPr id="9" name="Rectangle 8">
+            <a:extLst>
+              <a:ext uri="{FF2B5EF4-FFF2-40B4-BE49-F238E27FC236}">
+                <a16:creationId xmlns:a16="http://schemas.microsoft.com/office/drawing/2014/main" id="{F773E20D-34BA-2280-AAA8-70F00392F390}"/>
+              </a:ext>
+            </a:extLst>
+          </p:cNvPr>
+          <p:cNvSpPr/>
+          <p:nvPr/>
+        </p:nvSpPr>
+        <p:spPr>
+          <a:xfrm>
+            <a:off x="404191" y="1411605"/>
+            <a:ext cx="470452" cy="419601"/>
+          </a:xfrm>
+          <a:prstGeom prst="rect">
+            <a:avLst/>
+          </a:prstGeom>
+          <a:solidFill>
+            <a:schemeClr val="bg1"/>
+          </a:solidFill>
+          <a:ln>
+            <a:noFill/>
+          </a:ln>
+        </p:spPr>
+        <p:style>
+          <a:lnRef idx="2">
+            <a:schemeClr val="accent1">
+              <a:shade val="15000"/>
+            </a:schemeClr>
+          </a:lnRef>
+          <a:fillRef idx="1">
+            <a:schemeClr val="accent1"/>
+          </a:fillRef>
+          <a:effectRef idx="0">
+            <a:schemeClr val="accent1"/>
+          </a:effectRef>
+          <a:fontRef idx="minor">
+            <a:schemeClr val="lt1"/>
+          </a:fontRef>
+        </p:style>
+        <p:txBody>
+          <a:bodyPr rtlCol="0" anchor="ctr"/>
+          <a:lstStyle/>
+          <a:p>
+            <a:pPr algn="ctr"/>
+            <a:endParaRPr lang="en-US"/>
+          </a:p>
+        </p:txBody>
+      </p:sp>
       <p:sp>
         <p:nvSpPr>
           <p:cNvPr id="7" name="TextBox 6">
@@ -4132,7 +4481,7 @@
         </p:nvSpPr>
         <p:spPr>
           <a:xfrm>
-            <a:off x="540065" y="5134783"/>
+            <a:off x="586448" y="5291284"/>
             <a:ext cx="11019099" cy="461665"/>
           </a:xfrm>
           <a:prstGeom prst="rect">
@@ -4175,10 +4524,10 @@
       </p:sp>
       <p:pic>
         <p:nvPicPr>
-          <p:cNvPr id="4" name="Picture 3">
-            <a:extLst>
-              <a:ext uri="{FF2B5EF4-FFF2-40B4-BE49-F238E27FC236}">
-                <a16:creationId xmlns:a16="http://schemas.microsoft.com/office/drawing/2014/main" id="{75C9832C-3707-7D78-DE09-18D8659C6169}"/>
+          <p:cNvPr id="12" name="Picture 11">
+            <a:extLst>
+              <a:ext uri="{FF2B5EF4-FFF2-40B4-BE49-F238E27FC236}">
+                <a16:creationId xmlns:a16="http://schemas.microsoft.com/office/drawing/2014/main" id="{13B9E564-E961-EC68-E6AE-D080A3A87977}"/>
               </a:ext>
             </a:extLst>
           </p:cNvPr>
@@ -4188,51 +4537,16 @@
           <p:nvPr/>
         </p:nvPicPr>
         <p:blipFill>
-          <a:blip r:embed="rId2"/>
+          <a:blip r:embed="rId3"/>
+          <a:srcRect t="84824" r="59767"/>
           <a:stretch>
             <a:fillRect/>
           </a:stretch>
         </p:blipFill>
         <p:spPr>
           <a:xfrm>
-            <a:off x="331305" y="1044160"/>
-            <a:ext cx="6983895" cy="2347204"/>
-          </a:xfrm>
-          <a:prstGeom prst="rect">
-            <a:avLst/>
-          </a:prstGeom>
-        </p:spPr>
-      </p:pic>
-      <p:pic>
-        <p:nvPicPr>
-          <p:cNvPr id="8" name="Picture 7">
-            <a:extLst>
-              <a:ext uri="{FF2B5EF4-FFF2-40B4-BE49-F238E27FC236}">
-                <a16:creationId xmlns:a16="http://schemas.microsoft.com/office/drawing/2014/main" id="{DDB361A9-040A-6001-5D26-7147C9601C54}"/>
-              </a:ext>
-            </a:extLst>
-          </p:cNvPr>
-          <p:cNvPicPr>
-            <a:picLocks noChangeAspect="1"/>
-          </p:cNvPicPr>
-          <p:nvPr/>
-        </p:nvPicPr>
-        <p:blipFill>
-          <a:blip r:embed="rId3">
-            <a:extLst>
-              <a:ext uri="{28A0092B-C50C-407E-A947-70E740481C1C}">
-                <a14:useLocalDpi xmlns:a14="http://schemas.microsoft.com/office/drawing/2010/main" val="0"/>
-              </a:ext>
-            </a:extLst>
-          </a:blip>
-          <a:stretch>
-            <a:fillRect/>
-          </a:stretch>
-        </p:blipFill>
-        <p:spPr>
-          <a:xfrm>
-            <a:off x="7426250" y="1044160"/>
-            <a:ext cx="4655543" cy="2586936"/>
+            <a:off x="8322414" y="992004"/>
+            <a:ext cx="3309638" cy="419601"/>
           </a:xfrm>
           <a:prstGeom prst="rect">
             <a:avLst/>
@@ -4308,10 +4622,10 @@
       </p:pic>
       <p:sp>
         <p:nvSpPr>
-          <p:cNvPr id="10" name="Rectangle 9">
-            <a:extLst>
-              <a:ext uri="{FF2B5EF4-FFF2-40B4-BE49-F238E27FC236}">
-                <a16:creationId xmlns:a16="http://schemas.microsoft.com/office/drawing/2014/main" id="{6DC9E33E-18E6-65FE-D929-FA7631D7007C}"/>
+          <p:cNvPr id="2" name="Rectangle 1">
+            <a:extLst>
+              <a:ext uri="{FF2B5EF4-FFF2-40B4-BE49-F238E27FC236}">
+                <a16:creationId xmlns:a16="http://schemas.microsoft.com/office/drawing/2014/main" id="{3E713E4A-A76A-21B2-5D35-903A897D0FCE}"/>
               </a:ext>
             </a:extLst>
           </p:cNvPr>
@@ -4320,8 +4634,8 @@
         </p:nvSpPr>
         <p:spPr>
           <a:xfrm>
-            <a:off x="0" y="4632960"/>
-            <a:ext cx="12191999" cy="1465312"/>
+            <a:off x="0" y="4950116"/>
+            <a:ext cx="12191999" cy="1148155"/>
           </a:xfrm>
           <a:prstGeom prst="rect">
             <a:avLst/>
@@ -4374,7 +4688,7 @@
         </p:nvSpPr>
         <p:spPr>
           <a:xfrm>
-            <a:off x="586449" y="5134783"/>
+            <a:off x="586448" y="5293360"/>
             <a:ext cx="11019099" cy="461665"/>
           </a:xfrm>
           <a:prstGeom prst="rect">

</xml_diff>